<commit_message>
Final trained YOLO11n model (mAP@0.5 0.485), evaluation report, final IEEE paper and Phase-2 deck
Co-Authored-By: Claude Fable 5.1 <noreply@anthropic.com>
</commit_message>
<xml_diff>
--- a/ppt/Phase2_Review_Fire_Smoke_Detection.pptx
+++ b/ppt/Phase2_Review_Fire_Smoke_Detection.pptx
@@ -132,12 +132,12 @@
   <p:extLst>
     <p:ext uri="{521415D9-36F7-43E2-AB2F-B90AF26B5E84}">
       <p14:sectionLst xmlns:p14="http://schemas.microsoft.com/office/powerpoint/2010/main">
-        <p14:section name="Title" id="{42a70a00-2d8f-6a0d-0c6d-5ce5d26e9327}">
+        <p14:section name="Title" id="{86040f5a-ff9e-7fe7-b1df-86d989520288}">
           <p14:sldIdLst>
             <p14:sldId id="256"/>
           </p14:sldIdLst>
         </p14:section>
-        <p14:section name="1. Introduction" id="{0f7fe827-dab6-4e32-b1fe-854777781b76}">
+        <p14:section name="1. Introduction" id="{3d8b56f8-513a-c709-f9cc-417f649648eb}">
           <p14:sldIdLst>
             <p14:sldId id="257"/>
             <p14:sldId id="258"/>
@@ -145,27 +145,27 @@
             <p14:sldId id="260"/>
           </p14:sldIdLst>
         </p14:section>
-        <p14:section name="2. Problem Statement" id="{32301ef6-d3e4-2b70-8b74-22262d2060b6}">
+        <p14:section name="2. Problem Statement" id="{41ce00a2-7cc7-d357-89b6-6defc6d36070}">
           <p14:sldIdLst>
             <p14:sldId id="261"/>
             <p14:sldId id="262"/>
           </p14:sldIdLst>
         </p14:section>
-        <p14:section name="3. Literature Survey" id="{0c7054ce-a2c6-1e7d-7dbc-33690af1530a}">
+        <p14:section name="3. Literature Survey" id="{f03644a1-da85-2c28-659c-dae33b210f89}">
           <p14:sldIdLst>
             <p14:sldId id="263"/>
             <p14:sldId id="264"/>
             <p14:sldId id="265"/>
           </p14:sldIdLst>
         </p14:section>
-        <p14:section name="4. System Requirements" id="{5cfeca5e-1ea9-9d30-d54b-b66b6d7a8cd0}">
+        <p14:section name="4. System Requirements" id="{21efea2d-2855-29bf-52fe-dfc124e7436e}">
           <p14:sldIdLst>
             <p14:sldId id="266"/>
             <p14:sldId id="267"/>
             <p14:sldId id="268"/>
           </p14:sldIdLst>
         </p14:section>
-        <p14:section name="5. System Design" id="{e6b91352-a83a-6635-f4f5-fe6d835c9483}">
+        <p14:section name="5. System Design" id="{155bbbce-51b4-43db-4a22-6a4680e93b86}">
           <p14:sldIdLst>
             <p14:sldId id="269"/>
             <p14:sldId id="270"/>
@@ -173,7 +173,7 @@
             <p14:sldId id="272"/>
           </p14:sldIdLst>
         </p14:section>
-        <p14:section name="6. Implementation and Demonstration" id="{6c984945-b5ca-c5dc-02b0-4243c537189c}">
+        <p14:section name="6. Implementation and Demonstration" id="{2c317b07-e1c6-3953-4450-ea146e8e8a91}">
           <p14:sldIdLst>
             <p14:sldId id="273"/>
             <p14:sldId id="274"/>
@@ -183,7 +183,7 @@
             <p14:sldId id="278"/>
           </p14:sldIdLst>
         </p14:section>
-        <p14:section name="7. Paper Status" id="{e8490579-7ba8-e924-5a14-ae0a3030d215}">
+        <p14:section name="7. Paper Status" id="{7d86152a-4f32-2be3-e6e7-eaf583c2d657}">
           <p14:sldIdLst>
             <p14:sldId id="279"/>
             <p14:sldId id="280"/>
@@ -11879,7 +11879,7 @@
                   <a:schemeClr val="tx2"/>
                 </a:solidFill>
               </a:rPr>
-              <a:t>YOLOv11n fine-tuned from COCO weights: 416 px, batch 16, 10 epochs, AdamW, seed 42 — on CPU (~70 min).</a:t>
+              <a:t>YOLOv11n fine-tuned from COCO weights: 416 px, batch 16, 10 epochs, AdamW, seed 42 — on CPU (94.9 min).</a:t>
             </a:r>
             <a:endParaRPr lang="en-US" sz="1250" dirty="0"/>
           </a:p>
@@ -14469,7 +14469,7 @@
                             <a:srgbClr val="4A5563"/>
                           </a:solidFill>
                         </a:rPr>
-                        <a:t>0.504</a:t>
+                        <a:t>0.448</a:t>
                       </a:r>
                       <a:endParaRPr lang="en-US" sz="1100" dirty="0"/>
                     </a:p>
@@ -14530,7 +14530,7 @@
                             <a:srgbClr val="4A5563"/>
                           </a:solidFill>
                         </a:rPr>
-                        <a:t>0.398</a:t>
+                        <a:t>0.503</a:t>
                       </a:r>
                       <a:endParaRPr lang="en-US" sz="1100" dirty="0"/>
                     </a:p>
@@ -14591,7 +14591,7 @@
                             <a:srgbClr val="4A5563"/>
                           </a:solidFill>
                         </a:rPr>
-                        <a:t>0.445</a:t>
+                        <a:t>0.474</a:t>
                       </a:r>
                       <a:endParaRPr lang="en-US" sz="1100" dirty="0"/>
                     </a:p>
@@ -14652,7 +14652,7 @@
                             <a:srgbClr val="4A5563"/>
                           </a:solidFill>
                         </a:rPr>
-                        <a:t>0.383</a:t>
+                        <a:t>0.461</a:t>
                       </a:r>
                       <a:endParaRPr lang="en-US" sz="1100" dirty="0"/>
                     </a:p>
@@ -14713,7 +14713,7 @@
                             <a:srgbClr val="4A5563"/>
                           </a:solidFill>
                         </a:rPr>
-                        <a:t>0.179</a:t>
+                        <a:t>0.229</a:t>
                       </a:r>
                       <a:endParaRPr lang="en-US" sz="1100" dirty="0"/>
                     </a:p>
@@ -14837,7 +14837,7 @@
                             <a:srgbClr val="4A5563"/>
                           </a:solidFill>
                         </a:rPr>
-                        <a:t>0.505</a:t>
+                        <a:t>0.590</a:t>
                       </a:r>
                       <a:endParaRPr lang="en-US" sz="1100" dirty="0"/>
                     </a:p>
@@ -14898,7 +14898,7 @@
                             <a:srgbClr val="4A5563"/>
                           </a:solidFill>
                         </a:rPr>
-                        <a:t>0.479</a:t>
+                        <a:t>0.476</a:t>
                       </a:r>
                       <a:endParaRPr lang="en-US" sz="1100" dirty="0"/>
                     </a:p>
@@ -14959,7 +14959,7 @@
                             <a:srgbClr val="4A5563"/>
                           </a:solidFill>
                         </a:rPr>
-                        <a:t>0.492</a:t>
+                        <a:t>0.527</a:t>
                       </a:r>
                       <a:endParaRPr lang="en-US" sz="1100" dirty="0"/>
                     </a:p>
@@ -15020,7 +15020,7 @@
                             <a:srgbClr val="4A5563"/>
                           </a:solidFill>
                         </a:rPr>
-                        <a:t>0.450</a:t>
+                        <a:t>0.508</a:t>
                       </a:r>
                       <a:endParaRPr lang="en-US" sz="1100" dirty="0"/>
                     </a:p>
@@ -15081,7 +15081,7 @@
                             <a:srgbClr val="4A5563"/>
                           </a:solidFill>
                         </a:rPr>
-                        <a:t>0.217</a:t>
+                        <a:t>0.265</a:t>
                       </a:r>
                       <a:endParaRPr lang="en-US" sz="1100" dirty="0"/>
                     </a:p>
@@ -15205,7 +15205,7 @@
                             <a:srgbClr val="4A5563"/>
                           </a:solidFill>
                         </a:rPr>
-                        <a:t>0.505</a:t>
+                        <a:t>0.519</a:t>
                       </a:r>
                       <a:endParaRPr lang="en-US" sz="1100" dirty="0"/>
                     </a:p>
@@ -15266,7 +15266,7 @@
                             <a:srgbClr val="4A5563"/>
                           </a:solidFill>
                         </a:rPr>
-                        <a:t>0.438</a:t>
+                        <a:t>0.490</a:t>
                       </a:r>
                       <a:endParaRPr lang="en-US" sz="1100" dirty="0"/>
                     </a:p>
@@ -15327,7 +15327,7 @@
                             <a:srgbClr val="4A5563"/>
                           </a:solidFill>
                         </a:rPr>
-                        <a:t>0.469</a:t>
+                        <a:t>0.504</a:t>
                       </a:r>
                       <a:endParaRPr lang="en-US" sz="1100" dirty="0"/>
                     </a:p>
@@ -15388,7 +15388,7 @@
                             <a:srgbClr val="4A5563"/>
                           </a:solidFill>
                         </a:rPr>
-                        <a:t>0.416</a:t>
+                        <a:t>0.484</a:t>
                       </a:r>
                       <a:endParaRPr lang="en-US" sz="1100" dirty="0"/>
                     </a:p>
@@ -15449,7 +15449,7 @@
                             <a:srgbClr val="4A5563"/>
                           </a:solidFill>
                         </a:rPr>
-                        <a:t>0.198</a:t>
+                        <a:t>0.247</a:t>
                       </a:r>
                       <a:endParaRPr lang="en-US" sz="1100" dirty="0"/>
                     </a:p>
@@ -15531,7 +15531,7 @@
                   <a:schemeClr val="accent1"/>
                 </a:solidFill>
               </a:rPr>
-              <a:t>0.416</a:t>
+              <a:t>0.484</a:t>
             </a:r>
             <a:endParaRPr lang="en-US" sz="4000" dirty="0"/>
           </a:p>
@@ -15603,7 +15603,7 @@
                   <a:schemeClr val="accent4"/>
                 </a:solidFill>
               </a:rPr>
-              <a:t>59/60</a:t>
+              <a:t>60/60</a:t>
             </a:r>
             <a:endParaRPr lang="en-US" sz="4000" dirty="0"/>
           </a:p>
@@ -15647,7 +15647,7 @@
       </p:sp>
       <p:sp>
         <p:nvSpPr>
-          <p:cNvPr id="8" name="stat-CPU only, 117.6 ms per frame at 416 px"/>
+          <p:cNvPr id="8" name="stat-CPU only, 31.9 ms per frame at 416 px"/>
           <p:cNvSpPr txBox="1"/>
           <p:nvPr/>
         </p:nvSpPr>
@@ -15675,7 +15675,7 @@
                   <a:schemeClr val="accent6"/>
                 </a:solidFill>
               </a:rPr>
-              <a:t>8.5 fps</a:t>
+              <a:t>31.4 fps</a:t>
             </a:r>
             <a:endParaRPr lang="en-US" sz="4000" dirty="0"/>
           </a:p>
@@ -15683,7 +15683,7 @@
       </p:sp>
       <p:sp>
         <p:nvSpPr>
-          <p:cNvPr id="9" name="stat-label-CPU only, 117.6 ms per frame at 416 px"/>
+          <p:cNvPr id="9" name="stat-label-CPU only, 31.9 ms per frame at 416 px"/>
           <p:cNvSpPr txBox="1"/>
           <p:nvPr/>
         </p:nvSpPr>
@@ -15711,7 +15711,7 @@
                   <a:schemeClr val="tx2"/>
                 </a:solidFill>
               </a:rPr>
-              <a:t>CPU only, 117.6 ms per frame at 416 px</a:t>
+              <a:t>CPU only, 31.9 ms per frame at 416 px</a:t>
             </a:r>
             <a:endParaRPr lang="en-US" sz="1100" dirty="0"/>
           </a:p>
@@ -15751,7 +15751,7 @@
                   <a:schemeClr val="tx2"/>
                 </a:solidFill>
               </a:rPr>
-              <a:t>Operating point (conf 0.35, IoU 0.5): TP 328, FP 199, FN 699; the temporal engine filters isolated boxes before any alert.</a:t>
+              <a:t>Operating point (conf 0.35, IoU 0.5): TP 346, FP 159, FN 681; the temporal engine filters isolated boxes before any alert.</a:t>
             </a:r>
             <a:endParaRPr lang="en-US" sz="1150" dirty="0"/>
           </a:p>

</xml_diff>